<commit_message>
docs: update submission package documents, PPTX slides, and PDFs with authentication, 30 real cameras, and live deployment details
</commit_message>
<xml_diff>
--- a/submission_package/Sentinel_AI_Presentation_Final.pptx
+++ b/submission_package/Sentinel_AI_Presentation_Final.pptx
@@ -8653,7 +8653,7 @@
               </a:defRPr>
             </a:pPr>
             <a:r>
-              <a:t>📺 Live Multi-Cam Grid</a:t>
+              <a:t>📺 30 Live CCTV Grid</a:t>
             </a:r>
           </a:p>
           <a:p>
@@ -8668,7 +8668,7 @@
               </a:defRPr>
             </a:pPr>
             <a:r>
-              <a:t>1/4/9/16-channel WebRTC streams with AI bounding box overlays.</a:t>
+              <a:t>30 official Gujarat Police cameras with 60 FPS hardware HLS streams.</a:t>
             </a:r>
           </a:p>
         </p:txBody>
@@ -8733,7 +8733,7 @@
             <a:avLst/>
           </a:prstGeom>
           <a:solidFill>
-            <a:srgbClr val="EF4444"/>
+            <a:srgbClr val="10B981"/>
           </a:solidFill>
           <a:ln>
             <a:noFill/>
@@ -8791,7 +8791,7 @@
               </a:defRPr>
             </a:pPr>
             <a:r>
-              <a:t>🚨 Alert History &amp; Logs</a:t>
+              <a:t>🔒 Officer Security &amp; RBAC</a:t>
             </a:r>
           </a:p>
           <a:p>
@@ -8806,7 +8806,7 @@
               </a:defRPr>
             </a:pPr>
             <a:r>
-              <a:t>Real-time alert feed with 1-click acknowledgement and audit logs.</a:t>
+              <a:t>Salted SHA-256 gated login: SP IT &amp; Cyber (Badge: GP-7829).</a:t>
             </a:r>
           </a:p>
         </p:txBody>
@@ -8871,7 +8871,7 @@
             <a:avLst/>
           </a:prstGeom>
           <a:solidFill>
-            <a:srgbClr val="A855F7"/>
+            <a:srgbClr val="EF4444"/>
           </a:solidFill>
           <a:ln>
             <a:noFill/>
@@ -8929,7 +8929,7 @@
               </a:defRPr>
             </a:pPr>
             <a:r>
-              <a:t>🔎 Vehicle Search</a:t>
+              <a:t>🚨 Instant Hotlist Alerts</a:t>
             </a:r>
           </a:p>
           <a:p>
@@ -8944,7 +8944,7 @@
               </a:defRPr>
             </a:pPr>
             <a:r>
-              <a:t>Search by plate, location, vehicle class, and date/time windows.</a:t>
+              <a:t>Sub-second cross-reference against CCTNS stolen FIR watchlists.</a:t>
             </a:r>
           </a:p>
         </p:txBody>
@@ -9009,7 +9009,7 @@
             <a:avLst/>
           </a:prstGeom>
           <a:solidFill>
-            <a:srgbClr val="10B981"/>
+            <a:srgbClr val="A855F7"/>
           </a:solidFill>
           <a:ln>
             <a:noFill/>
@@ -9067,7 +9067,7 @@
               </a:defRPr>
             </a:pPr>
             <a:r>
-              <a:t>⚙️ Camera &amp; Hotlist Hub</a:t>
+              <a:t>🌐 Live Cloud Platform</a:t>
             </a:r>
           </a:p>
           <a:p>
@@ -9082,7 +9082,7 @@
               </a:defRPr>
             </a:pPr>
             <a:r>
-              <a:t>Bulk CSV import for CCTNS FIR lists &amp; camera management.</a:t>
+              <a:t>sentinel.deventtechnology.com with 24/7 keep-alive monitoring.</a:t>
             </a:r>
           </a:p>
         </p:txBody>
@@ -9162,7 +9162,7 @@
               </a:defRPr>
             </a:pPr>
             <a:r>
-              <a:t>&lt; 150ms</a:t>
+              <a:t>30 Feeds</a:t>
             </a:r>
           </a:p>
           <a:p>
@@ -9174,7 +9174,7 @@
               </a:defRPr>
             </a:pPr>
             <a:r>
-              <a:t>WebRTC Stream Latency</a:t>
+              <a:t>Live Gujarat Police Cameras</a:t>
             </a:r>
           </a:p>
         </p:txBody>
@@ -9204,12 +9204,12 @@
             <a:pPr algn="ctr">
               <a:defRPr sz="2200" b="1">
                 <a:solidFill>
-                  <a:srgbClr val="C084FC"/>
-                </a:solidFill>
-              </a:defRPr>
-            </a:pPr>
-            <a:r>
-              <a:t>100% Async</a:t>
+                  <a:srgbClr val="34D399"/>
+                </a:solidFill>
+              </a:defRPr>
+            </a:pPr>
+            <a:r>
+              <a:t>SHA-256</a:t>
             </a:r>
           </a:p>
           <a:p>
@@ -9221,7 +9221,7 @@
               </a:defRPr>
             </a:pPr>
             <a:r>
-              <a:t>Non-Blocking ASGI Core</a:t>
+              <a:t>Officer Security Gateway</a:t>
             </a:r>
           </a:p>
         </p:txBody>
@@ -9251,12 +9251,12 @@
             <a:pPr algn="ctr">
               <a:defRPr sz="2200" b="1">
                 <a:solidFill>
-                  <a:srgbClr val="34D399"/>
-                </a:solidFill>
-              </a:defRPr>
-            </a:pPr>
-            <a:r>
-              <a:t>Air-Gapped</a:t>
+                  <a:srgbClr val="F87171"/>
+                </a:solidFill>
+              </a:defRPr>
+            </a:pPr>
+            <a:r>
+              <a:t>&lt; 1s</a:t>
             </a:r>
           </a:p>
           <a:p>
@@ -9268,7 +9268,7 @@
               </a:defRPr>
             </a:pPr>
             <a:r>
-              <a:t>Zero External APIs</a:t>
+              <a:t>Hotlist Alert Latency</a:t>
             </a:r>
           </a:p>
         </p:txBody>
@@ -9303,7 +9303,7 @@
               </a:defRPr>
             </a:pPr>
             <a:r>
-              <a:t>CI/CD Ready</a:t>
+              <a:t>24/7 Live</a:t>
             </a:r>
           </a:p>
           <a:p>
@@ -9315,7 +9315,7 @@
               </a:defRPr>
             </a:pPr>
             <a:r>
-              <a:t>GitHub Actions Automated</a:t>
+              <a:t>Continuous Cloud Uptime</a:t>
             </a:r>
           </a:p>
         </p:txBody>
@@ -9465,7 +9465,7 @@
               </a:defRPr>
             </a:pPr>
             <a:r>
-              <a:t>Summary, Operational ROI &amp; Next Steps</a:t>
+              <a:t>Summary, Live Production Demo &amp; Next Steps</a:t>
             </a:r>
           </a:p>
         </p:txBody>
@@ -9500,7 +9500,7 @@
               </a:defRPr>
             </a:pPr>
             <a:r>
-              <a:t>High operational impact with massive recurring cost savings for government infrastructure.</a:t>
+              <a:t>High operational impact with verified production cloud availability.</a:t>
             </a:r>
           </a:p>
         </p:txBody>
@@ -9934,7 +9934,7 @@
               </a:defRPr>
             </a:pPr>
             <a:r>
-              <a:t>🚀 Future Roadmap Enhancements</a:t>
+              <a:t>🌐 Live Production Demo Access</a:t>
             </a:r>
           </a:p>
           <a:p>
@@ -9949,13 +9949,13 @@
               </a:defRPr>
             </a:pPr>
             <a:r>
-              <a:t>Phase 2 Capabilities</a:t>
+              <a:t>Direct Evaluation Access</a:t>
             </a:r>
           </a:p>
           <a:p>
             <a:pPr>
               <a:spcBef>
-                <a:spcPts val="1000"/>
+                <a:spcPts val="800"/>
               </a:spcBef>
               <a:defRPr sz="1100">
                 <a:solidFill>
@@ -9964,13 +9964,13 @@
               </a:defRPr>
             </a:pPr>
             <a:r>
-              <a:t>• Section-Control Speed Radar: Automated speed violation detection across long highway corridors.</a:t>
+              <a:t>• Live Web Dashboard: https://sentinel.deventtechnology.com</a:t>
             </a:r>
           </a:p>
           <a:p>
             <a:pPr>
               <a:spcBef>
-                <a:spcPts val="1000"/>
+                <a:spcPts val="800"/>
               </a:spcBef>
               <a:defRPr sz="1100">
                 <a:solidFill>
@@ -9979,13 +9979,13 @@
               </a:defRPr>
             </a:pPr>
             <a:r>
-              <a:t>• E-Challan Integration: Helmet, triple riding, and red-light violation detection modules.</a:t>
+              <a:t>• Live API Backend: https://sentinel-api-bqfm.onrender.com/docs</a:t>
             </a:r>
           </a:p>
           <a:p>
             <a:pPr>
               <a:spcBef>
-                <a:spcPts val="1000"/>
+                <a:spcPts val="800"/>
               </a:spcBef>
               <a:defRPr sz="1100">
                 <a:solidFill>
@@ -9994,13 +9994,13 @@
               </a:defRPr>
             </a:pPr>
             <a:r>
-              <a:t>• Edge AI Checkpoint Boxes: NVIDIA Jetson deployment for remote highway entry/exit toll plazas.</a:t>
+              <a:t>• Officer Login Email: jyoti@deventtechnology.com (Superintendent of Police)</a:t>
             </a:r>
           </a:p>
           <a:p>
             <a:pPr>
               <a:spcBef>
-                <a:spcPts val="1000"/>
+                <a:spcPts val="800"/>
               </a:spcBef>
               <a:defRPr sz="1100">
                 <a:solidFill>
@@ -10009,7 +10009,37 @@
               </a:defRPr>
             </a:pPr>
             <a:r>
-              <a:t>• Inter-District Police Sync: Federated hotlist sync across Ahmedabad, Surat, and Rajkot zones.</a:t>
+              <a:t>• Officer Password: 123456 (Badge Number: GP-7829)</a:t>
+            </a:r>
+          </a:p>
+          <a:p>
+            <a:pPr>
+              <a:spcBef>
+                <a:spcPts val="800"/>
+              </a:spcBef>
+              <a:defRPr sz="1100">
+                <a:solidFill>
+                  <a:srgbClr val="F8FAFC"/>
+                </a:solidFill>
+              </a:defRPr>
+            </a:pPr>
+            <a:r>
+              <a:t>• Active Feeds: 30 Official Gujarat Police Cameras (cam01 - cam30)</a:t>
+            </a:r>
+          </a:p>
+          <a:p>
+            <a:pPr>
+              <a:spcBef>
+                <a:spcPts val="800"/>
+              </a:spcBef>
+              <a:defRPr sz="1100">
+                <a:solidFill>
+                  <a:srgbClr val="F8FAFC"/>
+                </a:solidFill>
+              </a:defRPr>
+            </a:pPr>
+            <a:r>
+              <a:t>• Uptime Monitoring: Automated 24/7 keep-alive monitor enabled.</a:t>
             </a:r>
           </a:p>
         </p:txBody>

</xml_diff>